<commit_message>
docs(pitch): link the demo video and repository in the final deck
</commit_message>
<xml_diff>
--- a/docs/pitch/SurgeSight_TeamEcho.pptx
+++ b/docs/pitch/SurgeSight_TeamEcho.pptx
@@ -7584,11 +7584,8 @@
                 <a:ea typeface="Arial" pitchFamily="34" charset="-122"/>
                 <a:cs typeface="Arial" pitchFamily="34" charset="-120"/>
               </a:rPr>
-              <a:t>Demo video: [add link]</a:t>
-            </a:r>
-            <a:endParaRPr lang="en-US" sz="1150" dirty="0"/>
-          </a:p>
-          <a:p>
+              <a:t>Demo video: </a:t>
+            </a:r>
             <a:pPr algn="ctr" indent="0" marL="0">
               <a:spcAft>
                 <a:spcPts val="300"/>
@@ -7596,6 +7593,33 @@
               <a:buNone/>
             </a:pPr>
             <a:r>
+              <a:rPr lang="en-US" sz="1150" b="1" u="sng" dirty="0">
+                <a:solidFill>
+                  <a:srgbClr val="1967D2"/>
+                </a:solidFill>
+                <a:latin typeface="Arial" pitchFamily="34" charset="0"/>
+                <a:ea typeface="Arial" pitchFamily="34" charset="-122"/>
+                <a:cs typeface="Arial" pitchFamily="34" charset="-120"/>
+                <a:hlinkClick r:id="rId8" invalidUrl="" action="" tgtFrame="" tooltip="" history="1" highlightClick="0" endSnd="0">
+                  <a:extLst>
+                    <a:ext uri="{A12FA001-AC4F-418D-AE19-62706E023703}">
+                      <ahyp:hlinkClr xmlns:ahyp="http://schemas.microsoft.com/office/drawing/2018/hyperlinkcolor" val="tx"/>
+                    </a:ext>
+                  </a:extLst>
+                </a:hlinkClick>
+              </a:rPr>
+              <a:t>youtu.be/BeFNW2ZWFQM</a:t>
+            </a:r>
+            <a:endParaRPr lang="en-US" sz="1150" dirty="0"/>
+          </a:p>
+          <a:p>
+            <a:pPr algn="ctr" indent="0" marL="0">
+              <a:spcAft>
+                <a:spcPts val="300"/>
+              </a:spcAft>
+              <a:buNone/>
+            </a:pPr>
+            <a:r>
               <a:rPr lang="en-US" sz="1150" dirty="0">
                 <a:solidFill>
                   <a:srgbClr val="5F6368"/>
@@ -7604,7 +7628,31 @@
                 <a:ea typeface="Arial" pitchFamily="34" charset="-122"/>
                 <a:cs typeface="Arial" pitchFamily="34" charset="-120"/>
               </a:rPr>
-              <a:t>Code: [add link]</a:t>
+              <a:t>Code: </a:t>
+            </a:r>
+            <a:pPr algn="ctr" indent="0" marL="0">
+              <a:spcAft>
+                <a:spcPts val="300"/>
+              </a:spcAft>
+              <a:buNone/>
+            </a:pPr>
+            <a:r>
+              <a:rPr lang="en-US" sz="1150" b="1" u="sng" dirty="0">
+                <a:solidFill>
+                  <a:srgbClr val="1967D2"/>
+                </a:solidFill>
+                <a:latin typeface="Arial" pitchFamily="34" charset="0"/>
+                <a:ea typeface="Arial" pitchFamily="34" charset="-122"/>
+                <a:cs typeface="Arial" pitchFamily="34" charset="-120"/>
+                <a:hlinkClick r:id="rId9" invalidUrl="" action="" tgtFrame="" tooltip="" history="1" highlightClick="0" endSnd="0">
+                  <a:extLst>
+                    <a:ext uri="{A12FA001-AC4F-418D-AE19-62706E023703}">
+                      <ahyp:hlinkClr xmlns:ahyp="http://schemas.microsoft.com/office/drawing/2018/hyperlinkcolor" val="tx"/>
+                    </a:ext>
+                  </a:extLst>
+                </a:hlinkClick>
+              </a:rPr>
+              <a:t>gitlab.com/charanvelavan12/surgesight</a:t>
             </a:r>
             <a:endParaRPr lang="en-US" sz="1150" dirty="0"/>
           </a:p>

</xml_diff>